<commit_message>
Slides with the final 26B results (best value per column in bold, LLM judge finding); full win/tie/lose judge numbers in README and report
</commit_message>
<xml_diff>
--- a/docs/presentation/CodeMixESC_slides.pptx
+++ b/docs/presentation/CodeMixESC_slides.pptx
@@ -7210,7 +7210,7 @@
                 </a:solidFill>
                 <a:latin typeface="Arial"/>
               </a:rPr>
-              <a:t>C. Reply quality (first run: 31B agents, Light)</a:t>
+              <a:t>C. Reply quality (26B agents, same 50 turns)</a:t>
             </a:r>
           </a:p>
         </p:txBody>
@@ -7225,7 +7225,7 @@
         </p:nvGraphicFramePr>
         <p:xfrm>
           <a:off x="5029200" y="987552"/>
-          <a:ext cx="3749040" cy="1280160"/>
+          <a:ext cx="3749040" cy="1024128"/>
         </p:xfrm>
         <a:graphic>
           <a:graphicData uri="http://schemas.openxmlformats.org/drawingml/2006/table">
@@ -7234,12 +7234,12 @@
                 <a:tableStyleId>{5C22544A-7EE6-4342-B048-85BDC9FD1C3A}</a:tableStyleId>
               </a:tblPr>
               <a:tblGrid>
-                <a:gridCol w="1298448"/>
+                <a:gridCol w="1234440"/>
                 <a:gridCol w="502920"/>
-                <a:gridCol w="457200"/>
-                <a:gridCol w="484632"/>
-                <a:gridCol w="566928"/>
-                <a:gridCol w="438912"/>
+                <a:gridCol w="502920"/>
+                <a:gridCol w="548640"/>
+                <a:gridCol w="548640"/>
+                <a:gridCol w="411480"/>
               </a:tblGrid>
               <a:tr h="256032">
                 <a:tc>
@@ -7255,7 +7255,7 @@
                           </a:solidFill>
                           <a:latin typeface="Arial"/>
                         </a:rPr>
-                        <a:t>System (Light, 97 turns)</a:t>
+                        <a:t>System (50 turns)</a:t>
                       </a:r>
                     </a:p>
                   </a:txBody>
@@ -7278,7 +7278,7 @@
                           </a:solidFill>
                           <a:latin typeface="Arial"/>
                         </a:rPr>
-                        <a:t>R-L</a:t>
+                        <a:t>R-L Light</a:t>
                       </a:r>
                     </a:p>
                   </a:txBody>
@@ -7301,7 +7301,7 @@
                           </a:solidFill>
                           <a:latin typeface="Arial"/>
                         </a:rPr>
-                        <a:t>chrF</a:t>
+                        <a:t>R-L Heavy</a:t>
                       </a:r>
                     </a:p>
                   </a:txBody>
@@ -7324,7 +7324,7 @@
                           </a:solidFill>
                           <a:latin typeface="Arial"/>
                         </a:rPr>
-                        <a:t>BLEU-2</a:t>
+                        <a:t>CMI gap Light</a:t>
                       </a:r>
                     </a:p>
                   </a:txBody>
@@ -7347,7 +7347,7 @@
                           </a:solidFill>
                           <a:latin typeface="Arial"/>
                         </a:rPr>
-                        <a:t>CMI gap ↓</a:t>
+                        <a:t>CMI gap Heavy</a:t>
                       </a:r>
                     </a:p>
                   </a:txBody>
@@ -7395,7 +7395,7 @@
                           </a:solidFill>
                           <a:latin typeface="Arial"/>
                         </a:rPr>
-                        <a:t>MultiAgentESC (base)</a:t>
+                        <a:t>MultiAgentESC</a:t>
                       </a:r>
                     </a:p>
                   </a:txBody>
@@ -7418,7 +7418,7 @@
                           </a:solidFill>
                           <a:latin typeface="Arial"/>
                         </a:rPr>
-                        <a:t>11.42</a:t>
+                        <a:t>10.45</a:t>
                       </a:r>
                     </a:p>
                   </a:txBody>
@@ -7441,7 +7441,7 @@
                           </a:solidFill>
                           <a:latin typeface="Arial"/>
                         </a:rPr>
-                        <a:t>19.03</a:t>
+                        <a:t>5.66</a:t>
                       </a:r>
                     </a:p>
                   </a:txBody>
@@ -7464,7 +7464,7 @@
                           </a:solidFill>
                           <a:latin typeface="Arial"/>
                         </a:rPr>
-                        <a:t>7.43</a:t>
+                        <a:t>0.141</a:t>
                       </a:r>
                     </a:p>
                   </a:txBody>
@@ -7487,7 +7487,7 @@
                           </a:solidFill>
                           <a:latin typeface="Arial"/>
                         </a:rPr>
-                        <a:t>0.107</a:t>
+                        <a:t>0.357</a:t>
                       </a:r>
                     </a:p>
                   </a:txBody>
@@ -7510,7 +7510,7 @@
                           </a:solidFill>
                           <a:latin typeface="Arial"/>
                         </a:rPr>
-                        <a:t>6.31</a:t>
+                        <a:t>10.2</a:t>
                       </a:r>
                     </a:p>
                   </a:txBody>
@@ -7558,7 +7558,7 @@
                           </a:solidFill>
                           <a:latin typeface="Arial"/>
                         </a:rPr>
-                        <a:t>6.74</a:t>
+                        <a:t>5.75</a:t>
                       </a:r>
                     </a:p>
                   </a:txBody>
@@ -7581,7 +7581,30 @@
                           </a:solidFill>
                           <a:latin typeface="Arial"/>
                         </a:rPr>
-                        <a:t>17.25</a:t>
+                        <a:t>8.62</a:t>
+                      </a:r>
+                    </a:p>
+                  </a:txBody>
+                  <a:tcPr marL="45720" marR="45720" marT="18288" marB="18288" anchor="ctr">
+                    <a:solidFill>
+                      <a:srgbClr val="F4F6F9"/>
+                    </a:solidFill>
+                  </a:tcPr>
+                </a:tc>
+                <a:tc>
+                  <a:txBody>
+                    <a:bodyPr wrap="square"/>
+                    <a:lstStyle/>
+                    <a:p>
+                      <a:pPr algn="ctr"/>
+                      <a:r>
+                        <a:rPr sz="850" b="1">
+                          <a:solidFill>
+                            <a:srgbClr val="1F2937"/>
+                          </a:solidFill>
+                          <a:latin typeface="Arial"/>
+                        </a:rPr>
+                        <a:t>0.136</a:t>
                       </a:r>
                     </a:p>
                   </a:txBody>
@@ -7604,7 +7627,7 @@
                           </a:solidFill>
                           <a:latin typeface="Arial"/>
                         </a:rPr>
-                        <a:t>3.37</a:t>
+                        <a:t>0.208</a:t>
                       </a:r>
                     </a:p>
                   </a:txBody>
@@ -7627,176 +7650,13 @@
                           </a:solidFill>
                           <a:latin typeface="Arial"/>
                         </a:rPr>
-                        <a:t>0.194</a:t>
+                        <a:t>11.2</a:t>
                       </a:r>
                     </a:p>
                   </a:txBody>
                   <a:tcPr marL="45720" marR="45720" marT="18288" marB="18288" anchor="ctr">
                     <a:solidFill>
                       <a:srgbClr val="F4F6F9"/>
-                    </a:solidFill>
-                  </a:tcPr>
-                </a:tc>
-                <a:tc>
-                  <a:txBody>
-                    <a:bodyPr wrap="square"/>
-                    <a:lstStyle/>
-                    <a:p>
-                      <a:pPr algn="ctr"/>
-                      <a:r>
-                        <a:rPr sz="850" b="0">
-                          <a:solidFill>
-                            <a:srgbClr val="1F2937"/>
-                          </a:solidFill>
-                          <a:latin typeface="Arial"/>
-                        </a:rPr>
-                        <a:t>8.03</a:t>
-                      </a:r>
-                    </a:p>
-                  </a:txBody>
-                  <a:tcPr marL="45720" marR="45720" marT="18288" marB="18288" anchor="ctr">
-                    <a:solidFill>
-                      <a:srgbClr val="F4F6F9"/>
-                    </a:solidFill>
-                  </a:tcPr>
-                </a:tc>
-              </a:tr>
-              <a:tr h="256032">
-                <a:tc>
-                  <a:txBody>
-                    <a:bodyPr wrap="square"/>
-                    <a:lstStyle/>
-                    <a:p>
-                      <a:pPr algn="l"/>
-                      <a:r>
-                        <a:rPr sz="850" b="0">
-                          <a:solidFill>
-                            <a:srgbClr val="1F2937"/>
-                          </a:solidFill>
-                          <a:latin typeface="Arial"/>
-                        </a:rPr>
-                        <a:t>CodeMixESC w/o Gate</a:t>
-                      </a:r>
-                    </a:p>
-                  </a:txBody>
-                  <a:tcPr marL="45720" marR="45720" marT="18288" marB="18288" anchor="ctr">
-                    <a:solidFill>
-                      <a:srgbClr val="FFFFFF"/>
-                    </a:solidFill>
-                  </a:tcPr>
-                </a:tc>
-                <a:tc>
-                  <a:txBody>
-                    <a:bodyPr wrap="square"/>
-                    <a:lstStyle/>
-                    <a:p>
-                      <a:pPr algn="ctr"/>
-                      <a:r>
-                        <a:rPr sz="850" b="0">
-                          <a:solidFill>
-                            <a:srgbClr val="1F2937"/>
-                          </a:solidFill>
-                          <a:latin typeface="Arial"/>
-                        </a:rPr>
-                        <a:t>12.33</a:t>
-                      </a:r>
-                    </a:p>
-                  </a:txBody>
-                  <a:tcPr marL="45720" marR="45720" marT="18288" marB="18288" anchor="ctr">
-                    <a:solidFill>
-                      <a:srgbClr val="FFFFFF"/>
-                    </a:solidFill>
-                  </a:tcPr>
-                </a:tc>
-                <a:tc>
-                  <a:txBody>
-                    <a:bodyPr wrap="square"/>
-                    <a:lstStyle/>
-                    <a:p>
-                      <a:pPr algn="ctr"/>
-                      <a:r>
-                        <a:rPr sz="850" b="0">
-                          <a:solidFill>
-                            <a:srgbClr val="1F2937"/>
-                          </a:solidFill>
-                          <a:latin typeface="Arial"/>
-                        </a:rPr>
-                        <a:t>19.28</a:t>
-                      </a:r>
-                    </a:p>
-                  </a:txBody>
-                  <a:tcPr marL="45720" marR="45720" marT="18288" marB="18288" anchor="ctr">
-                    <a:solidFill>
-                      <a:srgbClr val="FFFFFF"/>
-                    </a:solidFill>
-                  </a:tcPr>
-                </a:tc>
-                <a:tc>
-                  <a:txBody>
-                    <a:bodyPr wrap="square"/>
-                    <a:lstStyle/>
-                    <a:p>
-                      <a:pPr algn="ctr"/>
-                      <a:r>
-                        <a:rPr sz="850" b="0">
-                          <a:solidFill>
-                            <a:srgbClr val="1F2937"/>
-                          </a:solidFill>
-                          <a:latin typeface="Arial"/>
-                        </a:rPr>
-                        <a:t>7.95</a:t>
-                      </a:r>
-                    </a:p>
-                  </a:txBody>
-                  <a:tcPr marL="45720" marR="45720" marT="18288" marB="18288" anchor="ctr">
-                    <a:solidFill>
-                      <a:srgbClr val="FFFFFF"/>
-                    </a:solidFill>
-                  </a:tcPr>
-                </a:tc>
-                <a:tc>
-                  <a:txBody>
-                    <a:bodyPr wrap="square"/>
-                    <a:lstStyle/>
-                    <a:p>
-                      <a:pPr algn="ctr"/>
-                      <a:r>
-                        <a:rPr sz="850" b="0">
-                          <a:solidFill>
-                            <a:srgbClr val="1F2937"/>
-                          </a:solidFill>
-                          <a:latin typeface="Arial"/>
-                        </a:rPr>
-                        <a:t>0.125</a:t>
-                      </a:r>
-                    </a:p>
-                  </a:txBody>
-                  <a:tcPr marL="45720" marR="45720" marT="18288" marB="18288" anchor="ctr">
-                    <a:solidFill>
-                      <a:srgbClr val="FFFFFF"/>
-                    </a:solidFill>
-                  </a:tcPr>
-                </a:tc>
-                <a:tc>
-                  <a:txBody>
-                    <a:bodyPr wrap="square"/>
-                    <a:lstStyle/>
-                    <a:p>
-                      <a:pPr algn="ctr"/>
-                      <a:r>
-                        <a:rPr sz="850" b="0">
-                          <a:solidFill>
-                            <a:srgbClr val="1F2937"/>
-                          </a:solidFill>
-                          <a:latin typeface="Arial"/>
-                        </a:rPr>
-                        <a:t>6.35</a:t>
-                      </a:r>
-                    </a:p>
-                  </a:txBody>
-                  <a:tcPr marL="45720" marR="45720" marT="18288" marB="18288" anchor="ctr">
-                    <a:solidFill>
-                      <a:srgbClr val="FFFFFF"/>
                     </a:solidFill>
                   </a:tcPr>
                 </a:tc>
@@ -7838,7 +7698,7 @@
                           </a:solidFill>
                           <a:latin typeface="Arial"/>
                         </a:rPr>
-                        <a:t>12.69</a:t>
+                        <a:t>10.60</a:t>
                       </a:r>
                     </a:p>
                   </a:txBody>
@@ -7861,7 +7721,30 @@
                           </a:solidFill>
                           <a:latin typeface="Arial"/>
                         </a:rPr>
-                        <a:t>19.32</a:t>
+                        <a:t>9.24</a:t>
+                      </a:r>
+                    </a:p>
+                  </a:txBody>
+                  <a:tcPr marL="45720" marR="45720" marT="18288" marB="18288" anchor="ctr">
+                    <a:solidFill>
+                      <a:srgbClr val="FFF1E3"/>
+                    </a:solidFill>
+                  </a:tcPr>
+                </a:tc>
+                <a:tc>
+                  <a:txBody>
+                    <a:bodyPr wrap="square"/>
+                    <a:lstStyle/>
+                    <a:p>
+                      <a:pPr algn="ctr"/>
+                      <a:r>
+                        <a:rPr sz="850" b="0">
+                          <a:solidFill>
+                            <a:srgbClr val="1F2937"/>
+                          </a:solidFill>
+                          <a:latin typeface="Arial"/>
+                        </a:rPr>
+                        <a:t>0.137</a:t>
                       </a:r>
                     </a:p>
                   </a:txBody>
@@ -7884,30 +7767,7 @@
                           </a:solidFill>
                           <a:latin typeface="Arial"/>
                         </a:rPr>
-                        <a:t>8.14</a:t>
-                      </a:r>
-                    </a:p>
-                  </a:txBody>
-                  <a:tcPr marL="45720" marR="45720" marT="18288" marB="18288" anchor="ctr">
-                    <a:solidFill>
-                      <a:srgbClr val="FFF1E3"/>
-                    </a:solidFill>
-                  </a:tcPr>
-                </a:tc>
-                <a:tc>
-                  <a:txBody>
-                    <a:bodyPr wrap="square"/>
-                    <a:lstStyle/>
-                    <a:p>
-                      <a:pPr algn="ctr"/>
-                      <a:r>
-                        <a:rPr sz="850" b="1">
-                          <a:solidFill>
-                            <a:srgbClr val="1F2937"/>
-                          </a:solidFill>
-                          <a:latin typeface="Arial"/>
-                        </a:rPr>
-                        <a:t>0.101</a:t>
+                        <a:t>0.120</a:t>
                       </a:r>
                     </a:p>
                   </a:txBody>
@@ -7930,7 +7790,7 @@
                           </a:solidFill>
                           <a:latin typeface="Arial"/>
                         </a:rPr>
-                        <a:t>6.51</a:t>
+                        <a:t>10.7</a:t>
                       </a:r>
                     </a:p>
                   </a:txBody>
@@ -8789,7 +8649,59 @@
                 </a:solidFill>
                 <a:latin typeface="Arial"/>
               </a:rPr>
-              <a:t>• Replies: CodeMixESC beats MultiAgentESC on ROUGE-L (+1.27, p &lt; 0.05) and Translate-Pivot on every metric (p &lt; 0.01); the Register Gate cuts the CMI gap 0.125 → 0.101 (p &lt; 0.01) for only +0.2 LLM calls per turn.</a:t>
+              <a:t>• Replies (26B agents): Heavy vs MultiAgentESC: ROUGE-L +3.58 [+1.83, +5.27], p&lt;0.01; Light vs MultiAgentESC: ROUGE-L +0.15 [-1.75, +2.09], p=0.93; Register Gate CMI gap -0.017 [-0.033, -0.001], p=0.04.</a:t>
+            </a:r>
+          </a:p>
+          <a:p>
+            <a:pPr algn="l">
+              <a:spcAft>
+                <a:spcPts val="200"/>
+              </a:spcAft>
+            </a:pPr>
+            <a:r>
+              <a:rPr sz="950" b="0" i="0">
+                <a:solidFill>
+                  <a:srgbClr val="1F2937"/>
+                </a:solidFill>
+                <a:latin typeface="Arial"/>
+              </a:rPr>
+              <a:t>• LLM judge (gemma-4-31b, both orders): CodeMixESC preferred over MultiAgentESC overall in </a:t>
+            </a:r>
+            <a:r>
+              <a:rPr sz="950" b="1" i="0">
+                <a:solidFill>
+                  <a:srgbClr val="1F2937"/>
+                </a:solidFill>
+                <a:latin typeface="Arial"/>
+              </a:rPr>
+              <a:t>86% vs 4%</a:t>
+            </a:r>
+            <a:r>
+              <a:rPr sz="950" b="0" i="0">
+                <a:solidFill>
+                  <a:srgbClr val="1F2937"/>
+                </a:solidFill>
+                <a:latin typeface="Arial"/>
+              </a:rPr>
+              <a:t> of Heavy turns and </a:t>
+            </a:r>
+            <a:r>
+              <a:rPr sz="950" b="1" i="0">
+                <a:solidFill>
+                  <a:srgbClr val="1F2937"/>
+                </a:solidFill>
+                <a:latin typeface="Arial"/>
+              </a:rPr>
+              <a:t>74% vs 20%</a:t>
+            </a:r>
+            <a:r>
+              <a:rPr sz="950" b="0" i="0">
+                <a:solidFill>
+                  <a:srgbClr val="1F2937"/>
+                </a:solidFill>
+                <a:latin typeface="Arial"/>
+              </a:rPr>
+              <a:t> of Light turns (win vs loss, p &lt; 0.01).</a:t>
             </a:r>
           </a:p>
           <a:p>

</xml_diff>

<commit_message>
Fix Heavy mean CMI (0.34) and strategy-JSD units, test count, README order (final grid first, earlier 31B run after), docs state the LLM-only quality check
</commit_message>
<xml_diff>
--- a/docs/presentation/CodeMixESC_slides.pptx
+++ b/docs/presentation/CodeMixESC_slides.pptx
@@ -6265,7 +6265,7 @@
                 </a:solidFill>
                 <a:latin typeface="Arial"/>
               </a:rPr>
-              <a:t>First Hinglish ESC test set with strategy labels: ESConv test set rewritten at Light and Heavy mixing, CMI-verified.</a:t>
+              <a:t>Hinglish ESC test set with strategy labels (none known before): ESConv test set rewritten at Light and Heavy mixing, CMI-verified.</a:t>
             </a:r>
           </a:p>
         </p:txBody>
@@ -6372,7 +6372,7 @@
                 </a:solidFill>
                 <a:latin typeface="Arial"/>
               </a:rPr>
-              <a:t>designed the method; built ESConv-HiEn (LLM rewriting + CMI and meaning checks); built the 16,951 training pairs and fine-tuned the retriever; re-implemented MultiAgentESC with all four components and 4 baselines (zero-shot, few-shot CoT, MultiAgentESC, translate-pivot) + ablations; built the evaluation (BLEU, ROUGE-L, chrF, BERTScore, CMI gap, strategy JSD, LLM judge, conversation-level bootstrap) with 110 unit tests and CI.</a:t>
+              <a:t>designed the method; built ESConv-HiEn (LLM rewriting + CMI and meaning checks); built the 16,951 training pairs and fine-tuned the retriever; re-implemented MultiAgentESC with all four components and 4 baselines (zero-shot, few-shot CoT, MultiAgentESC, translate-pivot) + ablations; built the evaluation (BLEU, ROUGE-L, chrF, BERTScore, CMI gap, strategy JSD, LLM judge, conversation-level bootstrap) with 111 unit tests and CI.</a:t>
             </a:r>
           </a:p>
         </p:txBody>
@@ -7370,7 +7370,7 @@
                           </a:solidFill>
                           <a:latin typeface="Arial"/>
                         </a:rPr>
-                        <a:t>Calls</a:t>
+                        <a:t>Calls Heavy</a:t>
                       </a:r>
                     </a:p>
                   </a:txBody>
@@ -8633,7 +8633,7 @@
                 </a:solidFill>
                 <a:latin typeface="Arial"/>
               </a:rPr>
-              <a:t> (+26.3 points, 95% CI [24.6, 28.2]) and the retrieved strategies stay stable (JSD 0.15 → 0.01); trade-off: problem-type precision −2 to −4 points.</a:t>
+              <a:t> (+26.3 points, 95% CI [24.6, 28.2]); retrieved strategies stay stable (JSD 0.0015 → 0.00015); trade-off: problem-type precision −2 to −4 points.</a:t>
             </a:r>
           </a:p>
           <a:p>

</xml_diff>